<commit_message>
Plan slide: adopt the owner's edits; remove comparison and backup wording
Takes the owner's edited slide as canonical (spec now pelvic, aorta,
bariatric; onboarding end date TBD; review Jun-Jul 2027) and rewords the
Select stage so it describes qualification, not a bidding round: the
supplier that passes evaluation and qualification is onboarded. No
mention of a backup or of comparing plants against each other.

Co-Authored-By: Claude Fable 5.1 <noreply@anthropic.com>
Claude-Session: https://claude.ai/code/session_01JvB48tbAk8juvoi9bxkFTf
</commit_message>
<xml_diff>
--- a/Tissue Supplier Research/Supplier_Qualification_Plan.pptx
+++ b/Tissue Supplier Research/Supplier_Qualification_Plan.pptx
@@ -4,12 +4,12 @@
   <p:sldMasterIdLst>
     <p:sldMasterId id="2147483648" r:id="rId1"/>
   </p:sldMasterIdLst>
+  <p:notesMasterIdLst>
+    <p:notesMasterId r:id="rId3"/>
+  </p:notesMasterIdLst>
   <p:sldIdLst>
     <p:sldId id="256" r:id="rId2"/>
   </p:sldIdLst>
-  <p:notesMasterIdLst>
-    <p:notesMasterId r:id="rId3"/>
-  </p:notesMasterIdLst>
   <p:sldSz cx="12192000" cy="6858000"/>
   <p:notesSz cx="6858000" cy="12192000"/>
   <p:defaultTextStyle>
@@ -104,6 +104,11 @@
       </a:defRPr>
     </a:lvl9pPr>
   </p:defaultTextStyle>
+  <p:extLst>
+    <p:ext uri="{EFAFB233-063F-42B5-8137-9DF3F51BA10A}">
+      <p15:sldGuideLst xmlns:p15="http://schemas.microsoft.com/office/powerpoint/2012/main"/>
+    </p:ext>
+  </p:extLst>
 </p:presentation>
 </file>
 
@@ -129,234 +134,10 @@
           <a:chExt cx="0" cy="0"/>
         </a:xfrm>
       </p:grpSpPr>
-      <p:sp>
-        <p:nvSpPr>
-          <p:cNvPr id="2" name="Header Placeholder 1"/>
-          <p:cNvSpPr>
-            <a:spLocks noGrp="1"/>
-          </p:cNvSpPr>
-          <p:nvPr>
-            <p:ph type="hdr" sz="quarter"/>
-          </p:nvPr>
-        </p:nvSpPr>
-        <p:spPr>
-          <a:xfrm>
-            <a:off x="0" y="0"/>
-            <a:ext cx="2971800" cy="458788"/>
-          </a:xfrm>
-          <a:prstGeom prst="rect">
-            <a:avLst/>
-          </a:prstGeom>
-        </p:spPr>
-        <p:txBody>
-          <a:bodyPr vert="horz" lIns="91440" tIns="45720" rIns="91440" bIns="45720" rtlCol="0"/>
-          <a:lstStyle>
-            <a:lvl1pPr algn="l">
-              <a:defRPr sz="1200"/>
-            </a:lvl1pPr>
-          </a:lstStyle>
-          <a:p>
-            <a:endParaRPr lang="en-US"/>
-          </a:p>
-        </p:txBody>
-      </p:sp>
-      <p:sp>
-        <p:nvSpPr>
-          <p:cNvPr id="3" name="Date Placeholder 2"/>
-          <p:cNvSpPr>
-            <a:spLocks noGrp="1"/>
-          </p:cNvSpPr>
-          <p:nvPr>
-            <p:ph type="dt" idx="1"/>
-          </p:nvPr>
-        </p:nvSpPr>
-        <p:spPr>
-          <a:xfrm>
-            <a:off x="3884613" y="0"/>
-            <a:ext cx="2971800" cy="458788"/>
-          </a:xfrm>
-          <a:prstGeom prst="rect">
-            <a:avLst/>
-          </a:prstGeom>
-        </p:spPr>
-        <p:txBody>
-          <a:bodyPr vert="horz" lIns="91440" tIns="45720" rIns="91440" bIns="45720" rtlCol="0"/>
-          <a:lstStyle>
-            <a:lvl1pPr algn="r">
-              <a:defRPr sz="1200"/>
-            </a:lvl1pPr>
-          </a:lstStyle>
-          <a:p>
-            <a:fld id="{5282F153-3F37-0F45-9E97-73ACFA13230C}" type="datetimeFigureOut">
-              <a:rPr lang="en-US"/>
-              <a:t>7/23/19</a:t>
-            </a:fld>
-            <a:endParaRPr lang="en-US"/>
-          </a:p>
-        </p:txBody>
-      </p:sp>
-      <p:sp>
-        <p:nvSpPr>
-          <p:cNvPr id="4" name="Slide Image Placeholder 3"/>
-          <p:cNvSpPr>
-            <a:spLocks noGrp="1" noRot="1" noChangeAspect="1"/>
-          </p:cNvSpPr>
-          <p:nvPr>
-            <p:ph type="sldImg" idx="2"/>
-          </p:nvPr>
-        </p:nvSpPr>
-        <p:spPr>
-          <a:xfrm>
-            <a:off x="685800" y="1143000"/>
-            <a:ext cx="5486400" cy="3086100"/>
-          </a:xfrm>
-          <a:prstGeom prst="rect">
-            <a:avLst/>
-          </a:prstGeom>
-          <a:noFill/>
-          <a:ln w="12700">
-            <a:solidFill>
-              <a:prstClr val="black"/>
-            </a:solidFill>
-          </a:ln>
-        </p:spPr>
-        <p:txBody>
-          <a:bodyPr vert="horz" lIns="91440" tIns="45720" rIns="91440" bIns="45720" rtlCol="0" anchor="ctr"/>
-          <a:lstStyle/>
-          <a:p>
-            <a:endParaRPr lang="en-US"/>
-          </a:p>
-        </p:txBody>
-      </p:sp>
-      <p:sp>
-        <p:nvSpPr>
-          <p:cNvPr id="5" name="Notes Placeholder 4"/>
-          <p:cNvSpPr>
-            <a:spLocks noGrp="1"/>
-          </p:cNvSpPr>
-          <p:nvPr>
-            <p:ph type="body" sz="quarter" idx="3"/>
-          </p:nvPr>
-        </p:nvSpPr>
-        <p:spPr>
-          <a:xfrm>
-            <a:off x="685800" y="4400550"/>
-            <a:ext cx="5486400" cy="3600450"/>
-          </a:xfrm>
-          <a:prstGeom prst="rect">
-            <a:avLst/>
-          </a:prstGeom>
-        </p:spPr>
-        <p:txBody>
-          <a:bodyPr vert="horz" lIns="91440" tIns="45720" rIns="91440" bIns="45720" rtlCol="0"/>
-          <a:lstStyle/>
-          <a:p>
-            <a:pPr lvl="0"/>
-            <a:r>
-              <a:rPr lang="en-US"/>
-              <a:t>Click to edit Master text styles</a:t>
-            </a:r>
-          </a:p>
-          <a:p>
-            <a:pPr lvl="1"/>
-            <a:r>
-              <a:rPr lang="en-US"/>
-              <a:t>Second level</a:t>
-            </a:r>
-          </a:p>
-          <a:p>
-            <a:pPr lvl="2"/>
-            <a:r>
-              <a:rPr lang="en-US"/>
-              <a:t>Third level</a:t>
-            </a:r>
-          </a:p>
-          <a:p>
-            <a:pPr lvl="3"/>
-            <a:r>
-              <a:rPr lang="en-US"/>
-              <a:t>Fourth level</a:t>
-            </a:r>
-          </a:p>
-          <a:p>
-            <a:pPr lvl="4"/>
-            <a:r>
-              <a:rPr lang="en-US"/>
-              <a:t>Fifth level</a:t>
-            </a:r>
-          </a:p>
-        </p:txBody>
-      </p:sp>
-      <p:sp>
-        <p:nvSpPr>
-          <p:cNvPr id="6" name="Footer Placeholder 5"/>
-          <p:cNvSpPr>
-            <a:spLocks noGrp="1"/>
-          </p:cNvSpPr>
-          <p:nvPr>
-            <p:ph type="ftr" sz="quarter" idx="4"/>
-          </p:nvPr>
-        </p:nvSpPr>
-        <p:spPr>
-          <a:xfrm>
-            <a:off x="0" y="8685213"/>
-            <a:ext cx="2971800" cy="458787"/>
-          </a:xfrm>
-          <a:prstGeom prst="rect">
-            <a:avLst/>
-          </a:prstGeom>
-        </p:spPr>
-        <p:txBody>
-          <a:bodyPr vert="horz" lIns="91440" tIns="45720" rIns="91440" bIns="45720" rtlCol="0" anchor="b"/>
-          <a:lstStyle>
-            <a:lvl1pPr algn="l">
-              <a:defRPr sz="1200"/>
-            </a:lvl1pPr>
-          </a:lstStyle>
-          <a:p>
-            <a:endParaRPr lang="en-US"/>
-          </a:p>
-        </p:txBody>
-      </p:sp>
-      <p:sp>
-        <p:nvSpPr>
-          <p:cNvPr id="7" name="Slide Number Placeholder 6"/>
-          <p:cNvSpPr>
-            <a:spLocks noGrp="1"/>
-          </p:cNvSpPr>
-          <p:nvPr>
-            <p:ph type="sldNum" sz="quarter" idx="5"/>
-          </p:nvPr>
-        </p:nvSpPr>
-        <p:spPr>
-          <a:xfrm>
-            <a:off x="3884613" y="8685213"/>
-            <a:ext cx="2971800" cy="458787"/>
-          </a:xfrm>
-          <a:prstGeom prst="rect">
-            <a:avLst/>
-          </a:prstGeom>
-        </p:spPr>
-        <p:txBody>
-          <a:bodyPr vert="horz" lIns="91440" tIns="45720" rIns="91440" bIns="45720" rtlCol="0" anchor="b"/>
-          <a:lstStyle>
-            <a:lvl1pPr algn="r">
-              <a:defRPr sz="1200"/>
-            </a:lvl1pPr>
-          </a:lstStyle>
-          <a:p>
-            <a:fld id="{CE5E9CC1-C706-0F49-92D6-E571CC5EEA8F}" type="slidenum">
-              <a:rPr lang="en-US"/>
-              <a:t>‹#›</a:t>
-            </a:fld>
-            <a:endParaRPr lang="en-US"/>
-          </a:p>
-        </p:txBody>
-      </p:sp>
     </p:spTree>
     <p:extLst>
       <p:ext uri="{BB962C8B-B14F-4D97-AF65-F5344CB8AC3E}">
-        <p14:creationId xmlns:p14="http://schemas.microsoft.com/office/powerpoint/2010/main" val="1024086991"/>
+        <p14:creationId xmlns:p14="http://schemas.microsoft.com/office/powerpoint/2010/main" val="2192160885"/>
       </p:ext>
     </p:extLst>
   </p:cSld>
@@ -501,10 +282,8 @@
           <a:lstStyle/>
           <a:p>
             <a:r>
-              <a:rPr lang="en-US" dirty="0"/>
-              <a:t>Five-stage supplier qualification plan with entry gates, deliverables and exit gates. Dates as agreed 2026-09-28: calls complete Oct 29; visits Nov 2–Dec 18; pelvic pilot Dec 7–Jan 22; selection by Jan 27; onboarding Feb 2–Mar 27; reliable-product review Jun 30, 2027. Q3 milestone = Identified (Sep 30) with the workbook and shortlist memo as the deliverable.</a:t>
-            </a:r>
-            <a:endParaRPr lang="en-US" dirty="0"/>
+              <a:t>Five-stage supplier qualification plan with entry gates, deliverables and exit gates. Dates as agreed 2026-09-28: calls complete Oct 29; visits Nov 2–Dec 18; pilot Dec 7–Jan 22; selection by Jan 27; onboarding from Feb 2; reliable-product review Jun–Jul 2027. Once a supplier passes evaluation and qualification it is onboarded — there is no bidding round.</a:t>
+            </a:r>
           </a:p>
         </p:txBody>
       </p:sp>
@@ -577,6 +356,11 @@
 <file path=ppt/slideMasters/slideMaster1.xml><?xml version="1.0" encoding="utf-8"?>
 <p:sldMaster xmlns:a="http://schemas.openxmlformats.org/drawingml/2006/main" xmlns:r="http://schemas.openxmlformats.org/officeDocument/2006/relationships" xmlns:p="http://schemas.openxmlformats.org/presentationml/2006/main">
   <p:cSld>
+    <p:bg>
+      <p:bgRef idx="1001">
+        <a:schemeClr val="bg1"/>
+      </p:bgRef>
+    </p:bg>
     <p:spTree>
       <p:nvGrpSpPr>
         <p:cNvPr id="1" name=""/>
@@ -859,6 +643,7 @@
         <a:solidFill>
           <a:srgbClr val="FFFFFF"/>
         </a:solidFill>
+        <a:effectLst/>
       </p:bgPr>
     </p:bg>
     <p:spTree>
@@ -896,7 +681,7 @@
           <a:bodyPr wrap="square" lIns="0" tIns="0" rIns="0" bIns="0" rtlCol="0" anchor="ctr"/>
           <a:lstStyle/>
           <a:p>
-            <a:pPr indent="0" marL="0">
+            <a:pPr marL="0" indent="0">
               <a:buNone/>
             </a:pPr>
             <a:r>
@@ -935,7 +720,7 @@
           <a:bodyPr wrap="square" lIns="0" tIns="0" rIns="0" bIns="0" rtlCol="0" anchor="ctr"/>
           <a:lstStyle/>
           <a:p>
-            <a:pPr indent="0" marL="0">
+            <a:pPr marL="0" indent="0">
               <a:buNone/>
             </a:pPr>
             <a:r>
@@ -975,6 +760,13 @@
             <a:prstDash val="solid"/>
           </a:ln>
         </p:spPr>
+        <p:txBody>
+          <a:bodyPr/>
+          <a:lstStyle/>
+          <a:p>
+            <a:endParaRPr lang="en-US"/>
+          </a:p>
+        </p:txBody>
       </p:sp>
       <p:sp>
         <p:nvSpPr>
@@ -1000,6 +792,13 @@
             <a:prstDash val="solid"/>
           </a:ln>
         </p:spPr>
+        <p:txBody>
+          <a:bodyPr/>
+          <a:lstStyle/>
+          <a:p>
+            <a:endParaRPr lang="en-US"/>
+          </a:p>
+        </p:txBody>
       </p:sp>
       <p:sp>
         <p:nvSpPr>
@@ -1022,7 +821,7 @@
           <a:bodyPr wrap="square" lIns="0" tIns="0" rIns="0" bIns="0" rtlCol="0" anchor="ctr"/>
           <a:lstStyle/>
           <a:p>
-            <a:pPr algn="ctr" indent="0" marL="0">
+            <a:pPr marL="0" indent="0" algn="ctr">
               <a:buNone/>
             </a:pPr>
             <a:r>
@@ -1061,7 +860,7 @@
           <a:bodyPr wrap="square" lIns="0" tIns="0" rIns="0" bIns="0" rtlCol="0" anchor="t"/>
           <a:lstStyle/>
           <a:p>
-            <a:pPr algn="ctr" indent="0" marL="0">
+            <a:pPr marL="0" indent="0" algn="ctr">
               <a:buNone/>
             </a:pPr>
             <a:r>
@@ -1078,7 +877,7 @@
             <a:endParaRPr lang="en-US" sz="950" dirty="0"/>
           </a:p>
           <a:p>
-            <a:pPr algn="ctr" indent="0" marL="0">
+            <a:pPr marL="0" indent="0" algn="ctr">
               <a:buNone/>
             </a:pPr>
             <a:r>
@@ -1120,6 +919,13 @@
             <a:prstDash val="solid"/>
           </a:ln>
         </p:spPr>
+        <p:txBody>
+          <a:bodyPr/>
+          <a:lstStyle/>
+          <a:p>
+            <a:endParaRPr lang="en-US"/>
+          </a:p>
+        </p:txBody>
       </p:sp>
       <p:sp>
         <p:nvSpPr>
@@ -1142,7 +948,7 @@
           <a:bodyPr wrap="square" lIns="0" tIns="0" rIns="0" bIns="0" rtlCol="0" anchor="ctr"/>
           <a:lstStyle/>
           <a:p>
-            <a:pPr algn="ctr" indent="0" marL="0">
+            <a:pPr marL="0" indent="0" algn="ctr">
               <a:buNone/>
             </a:pPr>
             <a:r>
@@ -1181,7 +987,7 @@
           <a:bodyPr wrap="square" lIns="0" tIns="0" rIns="0" bIns="0" rtlCol="0" anchor="t"/>
           <a:lstStyle/>
           <a:p>
-            <a:pPr algn="ctr" indent="0" marL="0">
+            <a:pPr marL="0" indent="0" algn="ctr">
               <a:buNone/>
             </a:pPr>
             <a:r>
@@ -1223,6 +1029,13 @@
             <a:prstDash val="solid"/>
           </a:ln>
         </p:spPr>
+        <p:txBody>
+          <a:bodyPr/>
+          <a:lstStyle/>
+          <a:p>
+            <a:endParaRPr lang="en-US"/>
+          </a:p>
+        </p:txBody>
       </p:sp>
       <p:sp>
         <p:nvSpPr>
@@ -1245,7 +1058,7 @@
           <a:bodyPr wrap="square" lIns="0" tIns="0" rIns="0" bIns="0" rtlCol="0" anchor="ctr"/>
           <a:lstStyle/>
           <a:p>
-            <a:pPr algn="ctr" indent="0" marL="0">
+            <a:pPr marL="0" indent="0" algn="ctr">
               <a:buNone/>
             </a:pPr>
             <a:r>
@@ -1284,7 +1097,7 @@
           <a:bodyPr wrap="square" lIns="0" tIns="0" rIns="0" bIns="0" rtlCol="0" anchor="t"/>
           <a:lstStyle/>
           <a:p>
-            <a:pPr algn="ctr" indent="0" marL="0">
+            <a:pPr marL="0" indent="0" algn="ctr">
               <a:buNone/>
             </a:pPr>
             <a:r>
@@ -1326,6 +1139,13 @@
             <a:prstDash val="solid"/>
           </a:ln>
         </p:spPr>
+        <p:txBody>
+          <a:bodyPr/>
+          <a:lstStyle/>
+          <a:p>
+            <a:endParaRPr lang="en-US"/>
+          </a:p>
+        </p:txBody>
       </p:sp>
       <p:sp>
         <p:nvSpPr>
@@ -1348,7 +1168,7 @@
           <a:bodyPr wrap="square" lIns="0" tIns="0" rIns="0" bIns="0" rtlCol="0" anchor="ctr"/>
           <a:lstStyle/>
           <a:p>
-            <a:pPr algn="ctr" indent="0" marL="0">
+            <a:pPr marL="0" indent="0" algn="ctr">
               <a:buNone/>
             </a:pPr>
             <a:r>
@@ -1387,7 +1207,7 @@
           <a:bodyPr wrap="square" lIns="0" tIns="0" rIns="0" bIns="0" rtlCol="0" anchor="t"/>
           <a:lstStyle/>
           <a:p>
-            <a:pPr algn="ctr" indent="0" marL="0">
+            <a:pPr marL="0" indent="0" algn="ctr">
               <a:buNone/>
             </a:pPr>
             <a:r>
@@ -1429,6 +1249,13 @@
             <a:prstDash val="solid"/>
           </a:ln>
         </p:spPr>
+        <p:txBody>
+          <a:bodyPr/>
+          <a:lstStyle/>
+          <a:p>
+            <a:endParaRPr lang="en-US"/>
+          </a:p>
+        </p:txBody>
       </p:sp>
       <p:sp>
         <p:nvSpPr>
@@ -1451,7 +1278,7 @@
           <a:bodyPr wrap="square" lIns="0" tIns="0" rIns="0" bIns="0" rtlCol="0" anchor="ctr"/>
           <a:lstStyle/>
           <a:p>
-            <a:pPr algn="ctr" indent="0" marL="0">
+            <a:pPr marL="0" indent="0" algn="ctr">
               <a:buNone/>
             </a:pPr>
             <a:r>
@@ -1490,7 +1317,7 @@
           <a:bodyPr wrap="square" lIns="0" tIns="0" rIns="0" bIns="0" rtlCol="0" anchor="t"/>
           <a:lstStyle/>
           <a:p>
-            <a:pPr algn="ctr" indent="0" marL="0">
+            <a:pPr marL="0" indent="0" algn="ctr">
               <a:buNone/>
             </a:pPr>
             <a:r>
@@ -1532,6 +1359,13 @@
             <a:prstDash val="solid"/>
           </a:ln>
         </p:spPr>
+        <p:txBody>
+          <a:bodyPr/>
+          <a:lstStyle/>
+          <a:p>
+            <a:endParaRPr lang="en-US"/>
+          </a:p>
+        </p:txBody>
       </p:sp>
       <p:sp>
         <p:nvSpPr>
@@ -1554,7 +1388,7 @@
           <a:bodyPr wrap="square" lIns="0" tIns="0" rIns="0" bIns="0" rtlCol="0" anchor="ctr"/>
           <a:lstStyle/>
           <a:p>
-            <a:pPr algn="ctr" indent="0" marL="0">
+            <a:pPr marL="0" indent="0" algn="ctr">
               <a:buNone/>
             </a:pPr>
             <a:r>
@@ -1593,7 +1427,7 @@
           <a:bodyPr wrap="square" lIns="0" tIns="0" rIns="0" bIns="0" rtlCol="0" anchor="t"/>
           <a:lstStyle/>
           <a:p>
-            <a:pPr algn="ctr" indent="0" marL="0">
+            <a:pPr marL="0" indent="0" algn="ctr">
               <a:buNone/>
             </a:pPr>
             <a:r>
@@ -1635,6 +1469,13 @@
             <a:prstDash val="solid"/>
           </a:ln>
         </p:spPr>
+        <p:txBody>
+          <a:bodyPr/>
+          <a:lstStyle/>
+          <a:p>
+            <a:endParaRPr lang="en-US"/>
+          </a:p>
+        </p:txBody>
       </p:sp>
       <p:sp>
         <p:nvSpPr>
@@ -1657,7 +1498,7 @@
           <a:bodyPr wrap="square" lIns="0" tIns="0" rIns="0" bIns="0" rtlCol="0" anchor="ctr"/>
           <a:lstStyle/>
           <a:p>
-            <a:pPr algn="ctr" indent="0" marL="0">
+            <a:pPr marL="0" indent="0" algn="ctr">
               <a:buNone/>
             </a:pPr>
             <a:r>
@@ -1669,7 +1510,7 @@
                 <a:ea typeface="Calibri" pitchFamily="34" charset="-122"/>
                 <a:cs typeface="Calibri" pitchFamily="34" charset="-120"/>
               </a:rPr>
-              <a:t>Jun 30, 2027</a:t>
+              <a:t>Jun -Jul, 2027</a:t>
             </a:r>
             <a:endParaRPr lang="en-US" sz="1050" dirty="0"/>
           </a:p>
@@ -1696,7 +1537,7 @@
           <a:bodyPr wrap="square" lIns="0" tIns="0" rIns="0" bIns="0" rtlCol="0" anchor="t"/>
           <a:lstStyle/>
           <a:p>
-            <a:pPr algn="ctr" indent="0" marL="0">
+            <a:pPr marL="0" indent="0" algn="ctr">
               <a:buNone/>
             </a:pPr>
             <a:r>
@@ -1713,7 +1554,7 @@
             <a:endParaRPr lang="en-US" sz="950" dirty="0"/>
           </a:p>
           <a:p>
-            <a:pPr algn="ctr" indent="0" marL="0">
+            <a:pPr marL="0" indent="0" algn="ctr">
               <a:buNone/>
             </a:pPr>
             <a:r>
@@ -1757,6 +1598,13 @@
             <a:prstDash val="solid"/>
           </a:ln>
         </p:spPr>
+        <p:txBody>
+          <a:bodyPr/>
+          <a:lstStyle/>
+          <a:p>
+            <a:endParaRPr lang="en-US"/>
+          </a:p>
+        </p:txBody>
       </p:sp>
       <p:sp>
         <p:nvSpPr>
@@ -1784,6 +1632,13 @@
             <a:prstDash val="solid"/>
           </a:ln>
         </p:spPr>
+        <p:txBody>
+          <a:bodyPr/>
+          <a:lstStyle/>
+          <a:p>
+            <a:endParaRPr lang="en-US"/>
+          </a:p>
+        </p:txBody>
       </p:sp>
       <p:sp>
         <p:nvSpPr>
@@ -1809,6 +1664,13 @@
             <a:prstDash val="solid"/>
           </a:ln>
         </p:spPr>
+        <p:txBody>
+          <a:bodyPr/>
+          <a:lstStyle/>
+          <a:p>
+            <a:endParaRPr lang="en-US"/>
+          </a:p>
+        </p:txBody>
       </p:sp>
       <p:sp>
         <p:nvSpPr>
@@ -1834,6 +1696,13 @@
             <a:prstDash val="solid"/>
           </a:ln>
         </p:spPr>
+        <p:txBody>
+          <a:bodyPr/>
+          <a:lstStyle/>
+          <a:p>
+            <a:endParaRPr lang="en-US"/>
+          </a:p>
+        </p:txBody>
       </p:sp>
       <p:sp>
         <p:nvSpPr>
@@ -1856,7 +1725,7 @@
           <a:bodyPr wrap="square" lIns="0" tIns="0" rIns="0" bIns="0" rtlCol="0" anchor="ctr"/>
           <a:lstStyle/>
           <a:p>
-            <a:pPr algn="ctr" indent="0" marL="0">
+            <a:pPr marL="0" indent="0" algn="ctr">
               <a:buNone/>
             </a:pPr>
             <a:r>
@@ -1895,7 +1764,7 @@
           <a:bodyPr wrap="square" lIns="0" tIns="0" rIns="0" bIns="0" rtlCol="0" anchor="ctr"/>
           <a:lstStyle/>
           <a:p>
-            <a:pPr indent="0" marL="0">
+            <a:pPr marL="0" indent="0">
               <a:buNone/>
             </a:pPr>
             <a:r>
@@ -1934,7 +1803,7 @@
           <a:bodyPr wrap="square" lIns="0" tIns="0" rIns="0" bIns="0" rtlCol="0" anchor="ctr"/>
           <a:lstStyle/>
           <a:p>
-            <a:pPr indent="0" marL="0">
+            <a:pPr marL="0" indent="0">
               <a:buNone/>
             </a:pPr>
             <a:r>
@@ -1973,7 +1842,7 @@
           <a:bodyPr wrap="square" lIns="0" tIns="0" rIns="0" bIns="0" rtlCol="0" anchor="t"/>
           <a:lstStyle/>
           <a:p>
-            <a:pPr indent="0" marL="0">
+            <a:pPr marL="0" indent="0">
               <a:lnSpc>
                 <a:spcPct val="105000"/>
               </a:lnSpc>
@@ -1993,7 +1862,7 @@
             <a:endParaRPr lang="en-US" sz="900" dirty="0"/>
           </a:p>
           <a:p>
-            <a:pPr indent="0" marL="0">
+            <a:pPr marL="0" indent="0">
               <a:lnSpc>
                 <a:spcPct val="105000"/>
               </a:lnSpc>
@@ -2013,7 +1882,7 @@
             <a:endParaRPr lang="en-US" sz="900" dirty="0"/>
           </a:p>
           <a:p>
-            <a:pPr indent="0" marL="0">
+            <a:pPr marL="0" indent="0">
               <a:lnSpc>
                 <a:spcPct val="105000"/>
               </a:lnSpc>
@@ -2036,7 +1905,7 @@
             <a:endParaRPr lang="en-US" sz="900" dirty="0"/>
           </a:p>
           <a:p>
-            <a:pPr indent="0" marL="0">
+            <a:pPr marL="0" indent="0">
               <a:lnSpc>
                 <a:spcPct val="105000"/>
               </a:lnSpc>
@@ -2056,7 +1925,7 @@
             <a:endParaRPr lang="en-US" sz="900" dirty="0"/>
           </a:p>
           <a:p>
-            <a:pPr indent="0" marL="0">
+            <a:pPr marL="0" indent="0">
               <a:lnSpc>
                 <a:spcPct val="105000"/>
               </a:lnSpc>
@@ -2079,7 +1948,7 @@
             <a:endParaRPr lang="en-US" sz="900" dirty="0"/>
           </a:p>
           <a:p>
-            <a:pPr indent="0" marL="0">
+            <a:pPr marL="0" indent="0">
               <a:lnSpc>
                 <a:spcPct val="105000"/>
               </a:lnSpc>
@@ -2099,7 +1968,7 @@
             <a:endParaRPr lang="en-US" sz="900" dirty="0"/>
           </a:p>
           <a:p>
-            <a:pPr indent="0" marL="0">
+            <a:pPr marL="0" indent="0">
               <a:lnSpc>
                 <a:spcPct val="105000"/>
               </a:lnSpc>
@@ -2122,7 +1991,7 @@
             <a:endParaRPr lang="en-US" sz="900" dirty="0"/>
           </a:p>
           <a:p>
-            <a:pPr indent="0" marL="0">
+            <a:pPr marL="0" indent="0">
               <a:lnSpc>
                 <a:spcPct val="105000"/>
               </a:lnSpc>
@@ -2169,6 +2038,13 @@
             <a:prstDash val="solid"/>
           </a:ln>
         </p:spPr>
+        <p:txBody>
+          <a:bodyPr/>
+          <a:lstStyle/>
+          <a:p>
+            <a:endParaRPr lang="en-US"/>
+          </a:p>
+        </p:txBody>
       </p:sp>
       <p:sp>
         <p:nvSpPr>
@@ -2196,6 +2072,13 @@
             <a:prstDash val="solid"/>
           </a:ln>
         </p:spPr>
+        <p:txBody>
+          <a:bodyPr/>
+          <a:lstStyle/>
+          <a:p>
+            <a:endParaRPr lang="en-US"/>
+          </a:p>
+        </p:txBody>
       </p:sp>
       <p:sp>
         <p:nvSpPr>
@@ -2221,6 +2104,13 @@
             <a:prstDash val="solid"/>
           </a:ln>
         </p:spPr>
+        <p:txBody>
+          <a:bodyPr/>
+          <a:lstStyle/>
+          <a:p>
+            <a:endParaRPr lang="en-US"/>
+          </a:p>
+        </p:txBody>
       </p:sp>
       <p:sp>
         <p:nvSpPr>
@@ -2246,6 +2136,13 @@
             <a:prstDash val="solid"/>
           </a:ln>
         </p:spPr>
+        <p:txBody>
+          <a:bodyPr/>
+          <a:lstStyle/>
+          <a:p>
+            <a:endParaRPr lang="en-US"/>
+          </a:p>
+        </p:txBody>
       </p:sp>
       <p:sp>
         <p:nvSpPr>
@@ -2268,7 +2165,7 @@
           <a:bodyPr wrap="square" lIns="0" tIns="0" rIns="0" bIns="0" rtlCol="0" anchor="ctr"/>
           <a:lstStyle/>
           <a:p>
-            <a:pPr algn="ctr" indent="0" marL="0">
+            <a:pPr marL="0" indent="0" algn="ctr">
               <a:buNone/>
             </a:pPr>
             <a:r>
@@ -2307,7 +2204,7 @@
           <a:bodyPr wrap="square" lIns="0" tIns="0" rIns="0" bIns="0" rtlCol="0" anchor="ctr"/>
           <a:lstStyle/>
           <a:p>
-            <a:pPr indent="0" marL="0">
+            <a:pPr marL="0" indent="0">
               <a:buNone/>
             </a:pPr>
             <a:r>
@@ -2346,7 +2243,7 @@
           <a:bodyPr wrap="square" lIns="0" tIns="0" rIns="0" bIns="0" rtlCol="0" anchor="ctr"/>
           <a:lstStyle/>
           <a:p>
-            <a:pPr indent="0" marL="0">
+            <a:pPr marL="0" indent="0">
               <a:buNone/>
             </a:pPr>
             <a:r>
@@ -2385,7 +2282,7 @@
           <a:bodyPr wrap="square" lIns="0" tIns="0" rIns="0" bIns="0" rtlCol="0" anchor="t"/>
           <a:lstStyle/>
           <a:p>
-            <a:pPr indent="0" marL="0">
+            <a:pPr marL="0" indent="0">
               <a:lnSpc>
                 <a:spcPct val="105000"/>
               </a:lnSpc>
@@ -2405,7 +2302,7 @@
             <a:endParaRPr lang="en-US" sz="900" dirty="0"/>
           </a:p>
           <a:p>
-            <a:pPr indent="0" marL="0">
+            <a:pPr marL="0" indent="0">
               <a:lnSpc>
                 <a:spcPct val="105000"/>
               </a:lnSpc>
@@ -2425,7 +2322,7 @@
             <a:endParaRPr lang="en-US" sz="900" dirty="0"/>
           </a:p>
           <a:p>
-            <a:pPr indent="0" marL="0">
+            <a:pPr marL="0" indent="0">
               <a:lnSpc>
                 <a:spcPct val="105000"/>
               </a:lnSpc>
@@ -2448,7 +2345,7 @@
             <a:endParaRPr lang="en-US" sz="900" dirty="0"/>
           </a:p>
           <a:p>
-            <a:pPr indent="0" marL="0">
+            <a:pPr marL="0" indent="0">
               <a:lnSpc>
                 <a:spcPct val="105000"/>
               </a:lnSpc>
@@ -2468,7 +2365,7 @@
             <a:endParaRPr lang="en-US" sz="900" dirty="0"/>
           </a:p>
           <a:p>
-            <a:pPr indent="0" marL="0">
+            <a:pPr marL="0" indent="0">
               <a:lnSpc>
                 <a:spcPct val="105000"/>
               </a:lnSpc>
@@ -2491,7 +2388,7 @@
             <a:endParaRPr lang="en-US" sz="900" dirty="0"/>
           </a:p>
           <a:p>
-            <a:pPr indent="0" marL="0">
+            <a:pPr marL="0" indent="0">
               <a:lnSpc>
                 <a:spcPct val="105000"/>
               </a:lnSpc>
@@ -2511,7 +2408,7 @@
             <a:endParaRPr lang="en-US" sz="900" dirty="0"/>
           </a:p>
           <a:p>
-            <a:pPr indent="0" marL="0">
+            <a:pPr marL="0" indent="0">
               <a:lnSpc>
                 <a:spcPct val="105000"/>
               </a:lnSpc>
@@ -2534,7 +2431,7 @@
             <a:endParaRPr lang="en-US" sz="900" dirty="0"/>
           </a:p>
           <a:p>
-            <a:pPr indent="0" marL="0">
+            <a:pPr marL="0" indent="0">
               <a:lnSpc>
                 <a:spcPct val="105000"/>
               </a:lnSpc>
@@ -2549,7 +2446,7 @@
                 <a:ea typeface="Calibri" pitchFamily="34" charset="-122"/>
                 <a:cs typeface="Calibri" pitchFamily="34" charset="-120"/>
               </a:rPr>
-              <a:t>At least one plant (ideally two) rated "qualified to pilot".</a:t>
+              <a:t>A plant rated "qualified to pilot".</a:t>
             </a:r>
             <a:endParaRPr lang="en-US" sz="900" dirty="0"/>
           </a:p>
@@ -2563,8 +2460,8 @@
         </p:nvSpPr>
         <p:spPr>
           <a:xfrm>
-            <a:off x="5021885" y="2331720"/>
-            <a:ext cx="2117750" cy="3794760"/>
+            <a:off x="5021885" y="2331719"/>
+            <a:ext cx="2117749" cy="3977639"/>
           </a:xfrm>
           <a:prstGeom prst="roundRect">
             <a:avLst>
@@ -2581,6 +2478,13 @@
             <a:prstDash val="solid"/>
           </a:ln>
         </p:spPr>
+        <p:txBody>
+          <a:bodyPr/>
+          <a:lstStyle/>
+          <a:p>
+            <a:endParaRPr lang="en-US"/>
+          </a:p>
+        </p:txBody>
       </p:sp>
       <p:sp>
         <p:nvSpPr>
@@ -2608,6 +2512,13 @@
             <a:prstDash val="solid"/>
           </a:ln>
         </p:spPr>
+        <p:txBody>
+          <a:bodyPr/>
+          <a:lstStyle/>
+          <a:p>
+            <a:endParaRPr lang="en-US"/>
+          </a:p>
+        </p:txBody>
       </p:sp>
       <p:sp>
         <p:nvSpPr>
@@ -2633,6 +2544,13 @@
             <a:prstDash val="solid"/>
           </a:ln>
         </p:spPr>
+        <p:txBody>
+          <a:bodyPr/>
+          <a:lstStyle/>
+          <a:p>
+            <a:endParaRPr lang="en-US"/>
+          </a:p>
+        </p:txBody>
       </p:sp>
       <p:sp>
         <p:nvSpPr>
@@ -2658,6 +2576,13 @@
             <a:prstDash val="solid"/>
           </a:ln>
         </p:spPr>
+        <p:txBody>
+          <a:bodyPr/>
+          <a:lstStyle/>
+          <a:p>
+            <a:endParaRPr lang="en-US"/>
+          </a:p>
+        </p:txBody>
       </p:sp>
       <p:sp>
         <p:nvSpPr>
@@ -2680,7 +2605,7 @@
           <a:bodyPr wrap="square" lIns="0" tIns="0" rIns="0" bIns="0" rtlCol="0" anchor="ctr"/>
           <a:lstStyle/>
           <a:p>
-            <a:pPr algn="ctr" indent="0" marL="0">
+            <a:pPr marL="0" indent="0" algn="ctr">
               <a:buNone/>
             </a:pPr>
             <a:r>
@@ -2719,7 +2644,7 @@
           <a:bodyPr wrap="square" lIns="0" tIns="0" rIns="0" bIns="0" rtlCol="0" anchor="ctr"/>
           <a:lstStyle/>
           <a:p>
-            <a:pPr indent="0" marL="0">
+            <a:pPr marL="0" indent="0">
               <a:buNone/>
             </a:pPr>
             <a:r>
@@ -2758,7 +2683,7 @@
           <a:bodyPr wrap="square" lIns="0" tIns="0" rIns="0" bIns="0" rtlCol="0" anchor="ctr"/>
           <a:lstStyle/>
           <a:p>
-            <a:pPr indent="0" marL="0">
+            <a:pPr marL="0" indent="0">
               <a:buNone/>
             </a:pPr>
             <a:r>
@@ -2797,7 +2722,7 @@
           <a:bodyPr wrap="square" lIns="0" tIns="0" rIns="0" bIns="0" rtlCol="0" anchor="t"/>
           <a:lstStyle/>
           <a:p>
-            <a:pPr indent="0" marL="0">
+            <a:pPr marL="0" indent="0">
               <a:lnSpc>
                 <a:spcPct val="105000"/>
               </a:lnSpc>
@@ -2817,7 +2742,7 @@
             <a:endParaRPr lang="en-US" sz="900" dirty="0"/>
           </a:p>
           <a:p>
-            <a:pPr indent="0" marL="0">
+            <a:pPr marL="0" indent="0">
               <a:lnSpc>
                 <a:spcPct val="105000"/>
               </a:lnSpc>
@@ -2832,12 +2757,12 @@
                 <a:ea typeface="Calibri" pitchFamily="34" charset="-122"/>
                 <a:cs typeface="Calibri" pitchFamily="34" charset="-120"/>
               </a:rPr>
-              <a:t>Qualified plant; paid pilot agreement; pelvic spec signed; inspector named; cold chain arranged.</a:t>
+              <a:t>Qualified plant; paid pilot agreement; (pelvic, aorta, bariatric) spec signed; inspector named; cold chain arranged.</a:t>
             </a:r>
             <a:endParaRPr lang="en-US" sz="900" dirty="0"/>
           </a:p>
           <a:p>
-            <a:pPr indent="0" marL="0">
+            <a:pPr marL="0" indent="0">
               <a:lnSpc>
                 <a:spcPct val="105000"/>
               </a:lnSpc>
@@ -2860,7 +2785,7 @@
             <a:endParaRPr lang="en-US" sz="900" dirty="0"/>
           </a:p>
           <a:p>
-            <a:pPr indent="0" marL="0">
+            <a:pPr marL="0" indent="0">
               <a:lnSpc>
                 <a:spcPct val="105000"/>
               </a:lnSpc>
@@ -2880,7 +2805,7 @@
             <a:endParaRPr lang="en-US" sz="900" dirty="0"/>
           </a:p>
           <a:p>
-            <a:pPr indent="0" marL="0">
+            <a:pPr marL="0" indent="0">
               <a:lnSpc>
                 <a:spcPct val="105000"/>
               </a:lnSpc>
@@ -2903,7 +2828,7 @@
             <a:endParaRPr lang="en-US" sz="900" dirty="0"/>
           </a:p>
           <a:p>
-            <a:pPr indent="0" marL="0">
+            <a:pPr marL="0" indent="0">
               <a:lnSpc>
                 <a:spcPct val="105000"/>
               </a:lnSpc>
@@ -2918,12 +2843,12 @@
                 <a:ea typeface="Calibri" pitchFamily="34" charset="-122"/>
                 <a:cs typeface="Calibri" pitchFamily="34" charset="-120"/>
               </a:rPr>
-              <a:t>Pilot report per plant: yield, inspection results, cost vs. model.</a:t>
+              <a:t>Pilot report: yield, inspection results, cost vs. model.</a:t>
             </a:r>
             <a:endParaRPr lang="en-US" sz="900" dirty="0"/>
           </a:p>
           <a:p>
-            <a:pPr indent="0" marL="0">
+            <a:pPr marL="0" indent="0">
               <a:lnSpc>
                 <a:spcPct val="105000"/>
               </a:lnSpc>
@@ -2946,7 +2871,7 @@
             <a:endParaRPr lang="en-US" sz="900" dirty="0"/>
           </a:p>
           <a:p>
-            <a:pPr indent="0" marL="0">
+            <a:pPr marL="0" indent="0">
               <a:lnSpc>
                 <a:spcPct val="105000"/>
               </a:lnSpc>
@@ -2993,6 +2918,13 @@
             <a:prstDash val="solid"/>
           </a:ln>
         </p:spPr>
+        <p:txBody>
+          <a:bodyPr/>
+          <a:lstStyle/>
+          <a:p>
+            <a:endParaRPr lang="en-US"/>
+          </a:p>
+        </p:txBody>
       </p:sp>
       <p:sp>
         <p:nvSpPr>
@@ -3020,6 +2952,13 @@
             <a:prstDash val="solid"/>
           </a:ln>
         </p:spPr>
+        <p:txBody>
+          <a:bodyPr/>
+          <a:lstStyle/>
+          <a:p>
+            <a:endParaRPr lang="en-US"/>
+          </a:p>
+        </p:txBody>
       </p:sp>
       <p:sp>
         <p:nvSpPr>
@@ -3045,6 +2984,13 @@
             <a:prstDash val="solid"/>
           </a:ln>
         </p:spPr>
+        <p:txBody>
+          <a:bodyPr/>
+          <a:lstStyle/>
+          <a:p>
+            <a:endParaRPr lang="en-US"/>
+          </a:p>
+        </p:txBody>
       </p:sp>
       <p:sp>
         <p:nvSpPr>
@@ -3070,6 +3016,13 @@
             <a:prstDash val="solid"/>
           </a:ln>
         </p:spPr>
+        <p:txBody>
+          <a:bodyPr/>
+          <a:lstStyle/>
+          <a:p>
+            <a:endParaRPr lang="en-US"/>
+          </a:p>
+        </p:txBody>
       </p:sp>
       <p:sp>
         <p:nvSpPr>
@@ -3092,7 +3045,7 @@
           <a:bodyPr wrap="square" lIns="0" tIns="0" rIns="0" bIns="0" rtlCol="0" anchor="ctr"/>
           <a:lstStyle/>
           <a:p>
-            <a:pPr algn="ctr" indent="0" marL="0">
+            <a:pPr marL="0" indent="0" algn="ctr">
               <a:buNone/>
             </a:pPr>
             <a:r>
@@ -3131,7 +3084,7 @@
           <a:bodyPr wrap="square" lIns="0" tIns="0" rIns="0" bIns="0" rtlCol="0" anchor="ctr"/>
           <a:lstStyle/>
           <a:p>
-            <a:pPr indent="0" marL="0">
+            <a:pPr marL="0" indent="0">
               <a:buNone/>
             </a:pPr>
             <a:r>
@@ -3170,7 +3123,7 @@
           <a:bodyPr wrap="square" lIns="0" tIns="0" rIns="0" bIns="0" rtlCol="0" anchor="ctr"/>
           <a:lstStyle/>
           <a:p>
-            <a:pPr indent="0" marL="0">
+            <a:pPr marL="0" indent="0">
               <a:buNone/>
             </a:pPr>
             <a:r>
@@ -3209,7 +3162,7 @@
           <a:bodyPr wrap="square" lIns="0" tIns="0" rIns="0" bIns="0" rtlCol="0" anchor="t"/>
           <a:lstStyle/>
           <a:p>
-            <a:pPr indent="0" marL="0">
+            <a:pPr marL="0" indent="0">
               <a:lnSpc>
                 <a:spcPct val="105000"/>
               </a:lnSpc>
@@ -3229,7 +3182,7 @@
             <a:endParaRPr lang="en-US" sz="900" dirty="0"/>
           </a:p>
           <a:p>
-            <a:pPr indent="0" marL="0">
+            <a:pPr marL="0" indent="0">
               <a:lnSpc>
                 <a:spcPct val="105000"/>
               </a:lnSpc>
@@ -3244,12 +3197,12 @@
                 <a:ea typeface="Calibri" pitchFamily="34" charset="-122"/>
                 <a:cs typeface="Calibri" pitchFamily="34" charset="-120"/>
               </a:rPr>
-              <a:t>Pilot reports for every piloted plant; Quality sign-off; commercial terms in writing.</a:t>
+              <a:t>Pilot report; Quality sign-off; commercial terms in writing.</a:t>
             </a:r>
             <a:endParaRPr lang="en-US" sz="900" dirty="0"/>
           </a:p>
           <a:p>
-            <a:pPr indent="0" marL="0">
+            <a:pPr marL="0" indent="0">
               <a:lnSpc>
                 <a:spcPct val="105000"/>
               </a:lnSpc>
@@ -3272,7 +3225,7 @@
             <a:endParaRPr lang="en-US" sz="900" dirty="0"/>
           </a:p>
           <a:p>
-            <a:pPr indent="0" marL="0">
+            <a:pPr marL="0" indent="0">
               <a:lnSpc>
                 <a:spcPct val="105000"/>
               </a:lnSpc>
@@ -3287,12 +3240,12 @@
                 <a:ea typeface="Calibri" pitchFamily="34" charset="-122"/>
                 <a:cs typeface="Calibri" pitchFamily="34" charset="-120"/>
               </a:rPr>
-              <a:t>Side-by-side comparison; one primary and one backup named.</a:t>
+              <a:t>Evaluation and qualification results reviewed; the supplier that passes is selected for onboarding.</a:t>
             </a:r>
             <a:endParaRPr lang="en-US" sz="900" dirty="0"/>
           </a:p>
           <a:p>
-            <a:pPr indent="0" marL="0">
+            <a:pPr marL="0" indent="0">
               <a:lnSpc>
                 <a:spcPct val="105000"/>
               </a:lnSpc>
@@ -3315,7 +3268,7 @@
             <a:endParaRPr lang="en-US" sz="900" dirty="0"/>
           </a:p>
           <a:p>
-            <a:pPr indent="0" marL="0">
+            <a:pPr marL="0" indent="0">
               <a:lnSpc>
                 <a:spcPct val="105000"/>
               </a:lnSpc>
@@ -3330,12 +3283,12 @@
                 <a:ea typeface="Calibri" pitchFamily="34" charset="-122"/>
                 <a:cs typeface="Calibri" pitchFamily="34" charset="-120"/>
               </a:rPr>
-              <a:t>Selection memo — why this plant, why not the others, terms, risks.</a:t>
+              <a:t>Selection memo — the evidence the supplier passed, terms, risks.</a:t>
             </a:r>
             <a:endParaRPr lang="en-US" sz="900" dirty="0"/>
           </a:p>
           <a:p>
-            <a:pPr indent="0" marL="0">
+            <a:pPr marL="0" indent="0">
               <a:lnSpc>
                 <a:spcPct val="105000"/>
               </a:lnSpc>
@@ -3358,7 +3311,7 @@
             <a:endParaRPr lang="en-US" sz="900" dirty="0"/>
           </a:p>
           <a:p>
-            <a:pPr indent="0" marL="0">
+            <a:pPr marL="0" indent="0">
               <a:lnSpc>
                 <a:spcPct val="105000"/>
               </a:lnSpc>
@@ -3388,7 +3341,7 @@
         <p:spPr>
           <a:xfrm>
             <a:off x="9586570" y="2331720"/>
-            <a:ext cx="2117750" cy="3794760"/>
+            <a:ext cx="2148230" cy="3900638"/>
           </a:xfrm>
           <a:prstGeom prst="roundRect">
             <a:avLst>
@@ -3405,6 +3358,13 @@
             <a:prstDash val="solid"/>
           </a:ln>
         </p:spPr>
+        <p:txBody>
+          <a:bodyPr/>
+          <a:lstStyle/>
+          <a:p>
+            <a:endParaRPr lang="en-US"/>
+          </a:p>
+        </p:txBody>
       </p:sp>
       <p:sp>
         <p:nvSpPr>
@@ -3432,6 +3392,13 @@
             <a:prstDash val="solid"/>
           </a:ln>
         </p:spPr>
+        <p:txBody>
+          <a:bodyPr/>
+          <a:lstStyle/>
+          <a:p>
+            <a:endParaRPr lang="en-US"/>
+          </a:p>
+        </p:txBody>
       </p:sp>
       <p:sp>
         <p:nvSpPr>
@@ -3457,6 +3424,13 @@
             <a:prstDash val="solid"/>
           </a:ln>
         </p:spPr>
+        <p:txBody>
+          <a:bodyPr/>
+          <a:lstStyle/>
+          <a:p>
+            <a:endParaRPr lang="en-US"/>
+          </a:p>
+        </p:txBody>
       </p:sp>
       <p:sp>
         <p:nvSpPr>
@@ -3482,6 +3456,13 @@
             <a:prstDash val="solid"/>
           </a:ln>
         </p:spPr>
+        <p:txBody>
+          <a:bodyPr/>
+          <a:lstStyle/>
+          <a:p>
+            <a:endParaRPr lang="en-US"/>
+          </a:p>
+        </p:txBody>
       </p:sp>
       <p:sp>
         <p:nvSpPr>
@@ -3504,7 +3485,7 @@
           <a:bodyPr wrap="square" lIns="0" tIns="0" rIns="0" bIns="0" rtlCol="0" anchor="ctr"/>
           <a:lstStyle/>
           <a:p>
-            <a:pPr algn="ctr" indent="0" marL="0">
+            <a:pPr marL="0" indent="0" algn="ctr">
               <a:buNone/>
             </a:pPr>
             <a:r>
@@ -3543,7 +3524,7 @@
           <a:bodyPr wrap="square" lIns="0" tIns="0" rIns="0" bIns="0" rtlCol="0" anchor="ctr"/>
           <a:lstStyle/>
           <a:p>
-            <a:pPr indent="0" marL="0">
+            <a:pPr marL="0" indent="0">
               <a:buNone/>
             </a:pPr>
             <a:r>
@@ -3582,7 +3563,7 @@
           <a:bodyPr wrap="square" lIns="0" tIns="0" rIns="0" bIns="0" rtlCol="0" anchor="ctr"/>
           <a:lstStyle/>
           <a:p>
-            <a:pPr indent="0" marL="0">
+            <a:pPr marL="0" indent="0">
               <a:buNone/>
             </a:pPr>
             <a:r>
@@ -3594,7 +3575,7 @@
                 <a:ea typeface="Calibri" pitchFamily="34" charset="-122"/>
                 <a:cs typeface="Calibri" pitchFamily="34" charset="-120"/>
               </a:rPr>
-              <a:t>Feb 2 → Mar 27</a:t>
+              <a:t>Feb 2 → TBD</a:t>
             </a:r>
             <a:endParaRPr lang="en-US" sz="1100" dirty="0"/>
           </a:p>
@@ -3621,7 +3602,7 @@
           <a:bodyPr wrap="square" lIns="0" tIns="0" rIns="0" bIns="0" rtlCol="0" anchor="t"/>
           <a:lstStyle/>
           <a:p>
-            <a:pPr indent="0" marL="0">
+            <a:pPr marL="0" indent="0">
               <a:lnSpc>
                 <a:spcPct val="105000"/>
               </a:lnSpc>
@@ -3641,7 +3622,7 @@
             <a:endParaRPr lang="en-US" sz="900" dirty="0"/>
           </a:p>
           <a:p>
-            <a:pPr indent="0" marL="0">
+            <a:pPr marL="0" indent="0">
               <a:lnSpc>
                 <a:spcPct val="105000"/>
               </a:lnSpc>
@@ -3661,7 +3642,7 @@
             <a:endParaRPr lang="en-US" sz="900" dirty="0"/>
           </a:p>
           <a:p>
-            <a:pPr indent="0" marL="0">
+            <a:pPr marL="0" indent="0">
               <a:lnSpc>
                 <a:spcPct val="105000"/>
               </a:lnSpc>
@@ -3684,7 +3665,7 @@
             <a:endParaRPr lang="en-US" sz="900" dirty="0"/>
           </a:p>
           <a:p>
-            <a:pPr indent="0" marL="0">
+            <a:pPr marL="0" indent="0">
               <a:lnSpc>
                 <a:spcPct val="105000"/>
               </a:lnSpc>
@@ -3704,7 +3685,7 @@
             <a:endParaRPr lang="en-US" sz="900" dirty="0"/>
           </a:p>
           <a:p>
-            <a:pPr indent="0" marL="0">
+            <a:pPr marL="0" indent="0">
               <a:lnSpc>
                 <a:spcPct val="105000"/>
               </a:lnSpc>
@@ -3727,7 +3708,7 @@
             <a:endParaRPr lang="en-US" sz="900" dirty="0"/>
           </a:p>
           <a:p>
-            <a:pPr indent="0" marL="0">
+            <a:pPr marL="0" indent="0">
               <a:lnSpc>
                 <a:spcPct val="105000"/>
               </a:lnSpc>
@@ -3747,7 +3728,7 @@
             <a:endParaRPr lang="en-US" sz="900" dirty="0"/>
           </a:p>
           <a:p>
-            <a:pPr indent="0" marL="0">
+            <a:pPr marL="0" indent="0">
               <a:lnSpc>
                 <a:spcPct val="105000"/>
               </a:lnSpc>
@@ -3770,7 +3751,7 @@
             <a:endParaRPr lang="en-US" sz="900" dirty="0"/>
           </a:p>
           <a:p>
-            <a:pPr indent="0" marL="0">
+            <a:pPr marL="0" indent="0">
               <a:lnSpc>
                 <a:spcPct val="105000"/>
               </a:lnSpc>
@@ -3785,7 +3766,7 @@
                 <a:ea typeface="Calibri" pitchFamily="34" charset="-122"/>
                 <a:cs typeface="Calibri" pitchFamily="34" charset="-120"/>
               </a:rPr>
-              <a:t>Three consecutive conforming production lots — then routine monitoring to the Jun 30 review.</a:t>
+              <a:t>Three consecutive conforming production lots — then routine monitoring to the Jun–Jul review.</a:t>
             </a:r>
             <a:endParaRPr lang="en-US" sz="900" dirty="0"/>
           </a:p>
@@ -3812,7 +3793,7 @@
           <a:bodyPr wrap="square" lIns="0" tIns="0" rIns="0" bIns="0" rtlCol="0" anchor="ctr"/>
           <a:lstStyle/>
           <a:p>
-            <a:pPr indent="0" marL="0">
+            <a:pPr marL="0" indent="0">
               <a:buNone/>
             </a:pPr>
             <a:r>
@@ -4131,4 +4112,319 @@
     </a:ext>
   </a:extLst>
 </a:theme>
+</file>
+
+<file path=ppt/theme/theme2.xml><?xml version="1.0" encoding="utf-8"?>
+<a:theme xmlns:a="http://schemas.openxmlformats.org/drawingml/2006/main" name="Office Theme">
+  <a:themeElements>
+    <a:clrScheme name="Office">
+      <a:dk1>
+        <a:sysClr val="windowText" lastClr="000000"/>
+      </a:dk1>
+      <a:lt1>
+        <a:sysClr val="window" lastClr="FFFFFF"/>
+      </a:lt1>
+      <a:dk2>
+        <a:srgbClr val="0E2841"/>
+      </a:dk2>
+      <a:lt2>
+        <a:srgbClr val="E8E8E8"/>
+      </a:lt2>
+      <a:accent1>
+        <a:srgbClr val="156082"/>
+      </a:accent1>
+      <a:accent2>
+        <a:srgbClr val="E97132"/>
+      </a:accent2>
+      <a:accent3>
+        <a:srgbClr val="196B24"/>
+      </a:accent3>
+      <a:accent4>
+        <a:srgbClr val="0F9ED5"/>
+      </a:accent4>
+      <a:accent5>
+        <a:srgbClr val="A02B93"/>
+      </a:accent5>
+      <a:accent6>
+        <a:srgbClr val="4EA72E"/>
+      </a:accent6>
+      <a:hlink>
+        <a:srgbClr val="467886"/>
+      </a:hlink>
+      <a:folHlink>
+        <a:srgbClr val="96607D"/>
+      </a:folHlink>
+    </a:clrScheme>
+    <a:fontScheme name="Office">
+      <a:majorFont>
+        <a:latin typeface="Aptos Display" panose="02110004020202020204"/>
+        <a:ea typeface=""/>
+        <a:cs typeface=""/>
+        <a:font script="Jpan" typeface="游ゴシック Light"/>
+        <a:font script="Hang" typeface="맑은 고딕"/>
+        <a:font script="Hans" typeface="等线 Light"/>
+        <a:font script="Hant" typeface="新細明體"/>
+        <a:font script="Arab" typeface="Times New Roman"/>
+        <a:font script="Hebr" typeface="Times New Roman"/>
+        <a:font script="Thai" typeface="Angsana New"/>
+        <a:font script="Ethi" typeface="Nyala"/>
+        <a:font script="Beng" typeface="Vrinda"/>
+        <a:font script="Gujr" typeface="Shruti"/>
+        <a:font script="Khmr" typeface="MoolBoran"/>
+        <a:font script="Knda" typeface="Tunga"/>
+        <a:font script="Guru" typeface="Raavi"/>
+        <a:font script="Cans" typeface="Euphemia"/>
+        <a:font script="Cher" typeface="Plantagenet Cherokee"/>
+        <a:font script="Yiii" typeface="Microsoft Yi Baiti"/>
+        <a:font script="Tibt" typeface="Microsoft Himalaya"/>
+        <a:font script="Thaa" typeface="MV Boli"/>
+        <a:font script="Deva" typeface="Mangal"/>
+        <a:font script="Telu" typeface="Gautami"/>
+        <a:font script="Taml" typeface="Latha"/>
+        <a:font script="Syrc" typeface="Estrangelo Edessa"/>
+        <a:font script="Orya" typeface="Kalinga"/>
+        <a:font script="Mlym" typeface="Kartika"/>
+        <a:font script="Laoo" typeface="DokChampa"/>
+        <a:font script="Sinh" typeface="Iskoola Pota"/>
+        <a:font script="Mong" typeface="Mongolian Baiti"/>
+        <a:font script="Viet" typeface="Times New Roman"/>
+        <a:font script="Uigh" typeface="Microsoft Uighur"/>
+        <a:font script="Geor" typeface="Sylfaen"/>
+        <a:font script="Armn" typeface="Arial"/>
+        <a:font script="Bugi" typeface="Leelawadee UI"/>
+        <a:font script="Bopo" typeface="Microsoft JhengHei"/>
+        <a:font script="Java" typeface="Javanese Text"/>
+        <a:font script="Lisu" typeface="Segoe UI"/>
+        <a:font script="Mymr" typeface="Myanmar Text"/>
+        <a:font script="Nkoo" typeface="Ebrima"/>
+        <a:font script="Olck" typeface="Nirmala UI"/>
+        <a:font script="Osma" typeface="Ebrima"/>
+        <a:font script="Phag" typeface="Phagspa"/>
+        <a:font script="Syrn" typeface="Estrangelo Edessa"/>
+        <a:font script="Syrj" typeface="Estrangelo Edessa"/>
+        <a:font script="Syre" typeface="Estrangelo Edessa"/>
+        <a:font script="Sora" typeface="Nirmala UI"/>
+        <a:font script="Tale" typeface="Microsoft Tai Le"/>
+        <a:font script="Talu" typeface="Microsoft New Tai Lue"/>
+        <a:font script="Tfng" typeface="Ebrima"/>
+      </a:majorFont>
+      <a:minorFont>
+        <a:latin typeface="Aptos" panose="02110004020202020204"/>
+        <a:ea typeface=""/>
+        <a:cs typeface=""/>
+        <a:font script="Jpan" typeface="游ゴシック"/>
+        <a:font script="Hang" typeface="맑은 고딕"/>
+        <a:font script="Hans" typeface="等线"/>
+        <a:font script="Hant" typeface="新細明體"/>
+        <a:font script="Arab" typeface="Arial"/>
+        <a:font script="Hebr" typeface="Arial"/>
+        <a:font script="Thai" typeface="Cordia New"/>
+        <a:font script="Ethi" typeface="Nyala"/>
+        <a:font script="Beng" typeface="Vrinda"/>
+        <a:font script="Gujr" typeface="Shruti"/>
+        <a:font script="Khmr" typeface="DaunPenh"/>
+        <a:font script="Knda" typeface="Tunga"/>
+        <a:font script="Guru" typeface="Raavi"/>
+        <a:font script="Cans" typeface="Euphemia"/>
+        <a:font script="Cher" typeface="Plantagenet Cherokee"/>
+        <a:font script="Yiii" typeface="Microsoft Yi Baiti"/>
+        <a:font script="Tibt" typeface="Microsoft Himalaya"/>
+        <a:font script="Thaa" typeface="MV Boli"/>
+        <a:font script="Deva" typeface="Mangal"/>
+        <a:font script="Telu" typeface="Gautami"/>
+        <a:font script="Taml" typeface="Latha"/>
+        <a:font script="Syrc" typeface="Estrangelo Edessa"/>
+        <a:font script="Orya" typeface="Kalinga"/>
+        <a:font script="Mlym" typeface="Kartika"/>
+        <a:font script="Laoo" typeface="DokChampa"/>
+        <a:font script="Sinh" typeface="Iskoola Pota"/>
+        <a:font script="Mong" typeface="Mongolian Baiti"/>
+        <a:font script="Viet" typeface="Arial"/>
+        <a:font script="Uigh" typeface="Microsoft Uighur"/>
+        <a:font script="Geor" typeface="Sylfaen"/>
+        <a:font script="Armn" typeface="Arial"/>
+        <a:font script="Bugi" typeface="Leelawadee UI"/>
+        <a:font script="Bopo" typeface="Microsoft JhengHei"/>
+        <a:font script="Java" typeface="Javanese Text"/>
+        <a:font script="Lisu" typeface="Segoe UI"/>
+        <a:font script="Mymr" typeface="Myanmar Text"/>
+        <a:font script="Nkoo" typeface="Ebrima"/>
+        <a:font script="Olck" typeface="Nirmala UI"/>
+        <a:font script="Osma" typeface="Ebrima"/>
+        <a:font script="Phag" typeface="Phagspa"/>
+        <a:font script="Syrn" typeface="Estrangelo Edessa"/>
+        <a:font script="Syrj" typeface="Estrangelo Edessa"/>
+        <a:font script="Syre" typeface="Estrangelo Edessa"/>
+        <a:font script="Sora" typeface="Nirmala UI"/>
+        <a:font script="Tale" typeface="Microsoft Tai Le"/>
+        <a:font script="Talu" typeface="Microsoft New Tai Lue"/>
+        <a:font script="Tfng" typeface="Ebrima"/>
+      </a:minorFont>
+    </a:fontScheme>
+    <a:fmtScheme name="Office">
+      <a:fillStyleLst>
+        <a:solidFill>
+          <a:schemeClr val="phClr"/>
+        </a:solidFill>
+        <a:gradFill rotWithShape="1">
+          <a:gsLst>
+            <a:gs pos="0">
+              <a:schemeClr val="phClr">
+                <a:lumMod val="110000"/>
+                <a:satMod val="105000"/>
+                <a:tint val="67000"/>
+              </a:schemeClr>
+            </a:gs>
+            <a:gs pos="50000">
+              <a:schemeClr val="phClr">
+                <a:lumMod val="105000"/>
+                <a:satMod val="103000"/>
+                <a:tint val="73000"/>
+              </a:schemeClr>
+            </a:gs>
+            <a:gs pos="100000">
+              <a:schemeClr val="phClr">
+                <a:lumMod val="105000"/>
+                <a:satMod val="109000"/>
+                <a:tint val="81000"/>
+              </a:schemeClr>
+            </a:gs>
+          </a:gsLst>
+          <a:lin ang="5400000" scaled="0"/>
+        </a:gradFill>
+        <a:gradFill rotWithShape="1">
+          <a:gsLst>
+            <a:gs pos="0">
+              <a:schemeClr val="phClr">
+                <a:satMod val="103000"/>
+                <a:lumMod val="102000"/>
+                <a:tint val="94000"/>
+              </a:schemeClr>
+            </a:gs>
+            <a:gs pos="50000">
+              <a:schemeClr val="phClr">
+                <a:satMod val="110000"/>
+                <a:lumMod val="100000"/>
+                <a:shade val="100000"/>
+              </a:schemeClr>
+            </a:gs>
+            <a:gs pos="100000">
+              <a:schemeClr val="phClr">
+                <a:lumMod val="99000"/>
+                <a:satMod val="120000"/>
+                <a:shade val="78000"/>
+              </a:schemeClr>
+            </a:gs>
+          </a:gsLst>
+          <a:lin ang="5400000" scaled="0"/>
+        </a:gradFill>
+      </a:fillStyleLst>
+      <a:lnStyleLst>
+        <a:ln w="12700" cap="flat" cmpd="sng" algn="ctr">
+          <a:solidFill>
+            <a:schemeClr val="phClr"/>
+          </a:solidFill>
+          <a:prstDash val="solid"/>
+          <a:miter lim="800000"/>
+        </a:ln>
+        <a:ln w="19050" cap="flat" cmpd="sng" algn="ctr">
+          <a:solidFill>
+            <a:schemeClr val="phClr"/>
+          </a:solidFill>
+          <a:prstDash val="solid"/>
+          <a:miter lim="800000"/>
+        </a:ln>
+        <a:ln w="25400" cap="flat" cmpd="sng" algn="ctr">
+          <a:solidFill>
+            <a:schemeClr val="phClr"/>
+          </a:solidFill>
+          <a:prstDash val="solid"/>
+          <a:miter lim="800000"/>
+        </a:ln>
+      </a:lnStyleLst>
+      <a:effectStyleLst>
+        <a:effectStyle>
+          <a:effectLst/>
+        </a:effectStyle>
+        <a:effectStyle>
+          <a:effectLst/>
+        </a:effectStyle>
+        <a:effectStyle>
+          <a:effectLst>
+            <a:outerShdw blurRad="57150" dist="19050" dir="5400000" algn="ctr" rotWithShape="0">
+              <a:srgbClr val="000000">
+                <a:alpha val="63000"/>
+              </a:srgbClr>
+            </a:outerShdw>
+          </a:effectLst>
+        </a:effectStyle>
+      </a:effectStyleLst>
+      <a:bgFillStyleLst>
+        <a:solidFill>
+          <a:schemeClr val="phClr"/>
+        </a:solidFill>
+        <a:solidFill>
+          <a:schemeClr val="phClr">
+            <a:tint val="95000"/>
+            <a:satMod val="170000"/>
+          </a:schemeClr>
+        </a:solidFill>
+        <a:gradFill rotWithShape="1">
+          <a:gsLst>
+            <a:gs pos="0">
+              <a:schemeClr val="phClr">
+                <a:tint val="93000"/>
+                <a:satMod val="150000"/>
+                <a:shade val="98000"/>
+                <a:lumMod val="102000"/>
+              </a:schemeClr>
+            </a:gs>
+            <a:gs pos="50000">
+              <a:schemeClr val="phClr">
+                <a:tint val="98000"/>
+                <a:satMod val="130000"/>
+                <a:shade val="90000"/>
+                <a:lumMod val="103000"/>
+              </a:schemeClr>
+            </a:gs>
+            <a:gs pos="100000">
+              <a:schemeClr val="phClr">
+                <a:shade val="63000"/>
+                <a:satMod val="120000"/>
+              </a:schemeClr>
+            </a:gs>
+          </a:gsLst>
+          <a:lin ang="5400000" scaled="0"/>
+        </a:gradFill>
+      </a:bgFillStyleLst>
+    </a:fmtScheme>
+  </a:themeElements>
+  <a:objectDefaults>
+    <a:lnDef>
+      <a:spPr/>
+      <a:bodyPr/>
+      <a:lstStyle/>
+      <a:style>
+        <a:lnRef idx="2">
+          <a:schemeClr val="accent1"/>
+        </a:lnRef>
+        <a:fillRef idx="0">
+          <a:schemeClr val="accent1"/>
+        </a:fillRef>
+        <a:effectRef idx="1">
+          <a:schemeClr val="accent1"/>
+        </a:effectRef>
+        <a:fontRef idx="minor">
+          <a:schemeClr val="tx1"/>
+        </a:fontRef>
+      </a:style>
+    </a:lnDef>
+  </a:objectDefaults>
+  <a:extraClrSchemeLst/>
+  <a:extLst>
+    <a:ext uri="{05A4C25C-085E-4340-85A3-A5531E510DB2}">
+      <thm15:themeFamily xmlns:thm15="http://schemas.microsoft.com/office/thememl/2012/main" name="Office Theme" id="{2E142A2C-CD16-42D6-873A-C26D2A0506FA}" vid="{1BDDFF52-6CD6-40A5-AB3C-68EB2F1E4D0A}"/>
+    </a:ext>
+  </a:extLst>
+</a:theme>
 </file>
</xml_diff>